<commit_message>
Reestructura y agregando funcionalidades
</commit_message>
<xml_diff>
--- a/templates/template.pptx
+++ b/templates/template.pptx
@@ -274,7 +274,7 @@
           <a:p>
             <a:fld id="{9C0EC74A-97EC-4D13-AC48-B7F39774675E}" type="datetimeFigureOut">
               <a:rPr lang="es-ES" smtClean="0"/>
-              <a:t>20/04/2026</a:t>
+              <a:t>27/04/2026</a:t>
             </a:fld>
             <a:endParaRPr lang="es-ES" dirty="0"/>
           </a:p>
@@ -440,7 +440,7 @@
           <a:p>
             <a:fld id="{10088373-C7C4-43EF-8EE4-15B3BD82BE94}" type="datetimeFigureOut">
               <a:rPr lang="es-ES" smtClean="0"/>
-              <a:t>20/04/2026</a:t>
+              <a:t>27/04/2026</a:t>
             </a:fld>
             <a:endParaRPr lang="es-ES" dirty="0"/>
           </a:p>
@@ -1456,7 +1456,7 @@
           <a:p>
             <a:fld id="{D184388A-CDDF-4860-AF28-3D21AC68C4D5}" type="datetime1">
               <a:rPr lang="es-ES" smtClean="0"/>
-              <a:t>20/04/2026</a:t>
+              <a:t>27/04/2026</a:t>
             </a:fld>
             <a:endParaRPr lang="es-ES" dirty="0"/>
           </a:p>
@@ -1624,7 +1624,7 @@
           <a:p>
             <a:fld id="{AF50F199-EC87-494F-81A5-8B1F1A78F27C}" type="datetime1">
               <a:rPr lang="es-ES" smtClean="0"/>
-              <a:t>20/04/2026</a:t>
+              <a:t>27/04/2026</a:t>
             </a:fld>
             <a:endParaRPr lang="es-ES" dirty="0"/>
           </a:p>
@@ -1816,7 +1816,7 @@
           <a:p>
             <a:fld id="{37013DEC-0FEE-4FF8-9051-DE981A23AC12}" type="datetimeFigureOut">
               <a:rPr lang="es-AR" smtClean="0"/>
-              <a:t>20/4/2026</a:t>
+              <a:t>27/4/2026</a:t>
             </a:fld>
             <a:endParaRPr lang="es-AR" dirty="0"/>
           </a:p>
@@ -1986,7 +1986,7 @@
           <a:p>
             <a:fld id="{37013DEC-0FEE-4FF8-9051-DE981A23AC12}" type="datetimeFigureOut">
               <a:rPr lang="es-AR" smtClean="0"/>
-              <a:t>20/4/2026</a:t>
+              <a:t>27/4/2026</a:t>
             </a:fld>
             <a:endParaRPr lang="es-AR" dirty="0"/>
           </a:p>
@@ -2232,7 +2232,7 @@
           <a:p>
             <a:fld id="{37013DEC-0FEE-4FF8-9051-DE981A23AC12}" type="datetimeFigureOut">
               <a:rPr lang="es-AR" smtClean="0"/>
-              <a:t>20/4/2026</a:t>
+              <a:t>27/4/2026</a:t>
             </a:fld>
             <a:endParaRPr lang="es-AR" dirty="0"/>
           </a:p>
@@ -2464,7 +2464,7 @@
           <a:p>
             <a:fld id="{37013DEC-0FEE-4FF8-9051-DE981A23AC12}" type="datetimeFigureOut">
               <a:rPr lang="es-AR" smtClean="0"/>
-              <a:t>20/4/2026</a:t>
+              <a:t>27/4/2026</a:t>
             </a:fld>
             <a:endParaRPr lang="es-AR" dirty="0"/>
           </a:p>
@@ -2831,7 +2831,7 @@
           <a:p>
             <a:fld id="{37013DEC-0FEE-4FF8-9051-DE981A23AC12}" type="datetimeFigureOut">
               <a:rPr lang="es-AR" smtClean="0"/>
-              <a:t>20/4/2026</a:t>
+              <a:t>27/4/2026</a:t>
             </a:fld>
             <a:endParaRPr lang="es-AR" dirty="0"/>
           </a:p>
@@ -2949,7 +2949,7 @@
           <a:p>
             <a:fld id="{37013DEC-0FEE-4FF8-9051-DE981A23AC12}" type="datetimeFigureOut">
               <a:rPr lang="es-AR" smtClean="0"/>
-              <a:t>20/4/2026</a:t>
+              <a:t>27/4/2026</a:t>
             </a:fld>
             <a:endParaRPr lang="es-AR" dirty="0"/>
           </a:p>
@@ -3044,7 +3044,7 @@
           <a:p>
             <a:fld id="{37013DEC-0FEE-4FF8-9051-DE981A23AC12}" type="datetimeFigureOut">
               <a:rPr lang="es-AR" smtClean="0"/>
-              <a:t>20/4/2026</a:t>
+              <a:t>27/4/2026</a:t>
             </a:fld>
             <a:endParaRPr lang="es-AR" dirty="0"/>
           </a:p>
@@ -3321,7 +3321,7 @@
           <a:p>
             <a:fld id="{37013DEC-0FEE-4FF8-9051-DE981A23AC12}" type="datetimeFigureOut">
               <a:rPr lang="es-AR" smtClean="0"/>
-              <a:t>20/4/2026</a:t>
+              <a:t>27/4/2026</a:t>
             </a:fld>
             <a:endParaRPr lang="es-AR" dirty="0"/>
           </a:p>
@@ -3574,7 +3574,7 @@
           <a:p>
             <a:fld id="{37013DEC-0FEE-4FF8-9051-DE981A23AC12}" type="datetimeFigureOut">
               <a:rPr lang="es-AR" smtClean="0"/>
-              <a:t>20/4/2026</a:t>
+              <a:t>27/4/2026</a:t>
             </a:fld>
             <a:endParaRPr lang="es-AR" dirty="0"/>
           </a:p>
@@ -3742,7 +3742,7 @@
           <a:p>
             <a:fld id="{669CF9DF-1B42-4005-BE0B-F4489D843B44}" type="datetime1">
               <a:rPr lang="es-ES" smtClean="0"/>
-              <a:t>20/04/2026</a:t>
+              <a:t>27/04/2026</a:t>
             </a:fld>
             <a:endParaRPr lang="es-ES" dirty="0"/>
           </a:p>
@@ -3912,7 +3912,7 @@
           <a:p>
             <a:fld id="{37013DEC-0FEE-4FF8-9051-DE981A23AC12}" type="datetimeFigureOut">
               <a:rPr lang="es-AR" smtClean="0"/>
-              <a:t>20/4/2026</a:t>
+              <a:t>27/4/2026</a:t>
             </a:fld>
             <a:endParaRPr lang="es-AR" dirty="0"/>
           </a:p>
@@ -4092,7 +4092,7 @@
           <a:p>
             <a:fld id="{37013DEC-0FEE-4FF8-9051-DE981A23AC12}" type="datetimeFigureOut">
               <a:rPr lang="es-AR" smtClean="0"/>
-              <a:t>20/4/2026</a:t>
+              <a:t>27/4/2026</a:t>
             </a:fld>
             <a:endParaRPr lang="es-AR" dirty="0"/>
           </a:p>
@@ -4337,7 +4337,7 @@
           <a:p>
             <a:fld id="{50661095-153F-4BE4-8633-EE56D76CA864}" type="datetime1">
               <a:rPr lang="es-ES" smtClean="0"/>
-              <a:t>20/04/2026</a:t>
+              <a:t>27/04/2026</a:t>
             </a:fld>
             <a:endParaRPr lang="es-ES" dirty="0"/>
           </a:p>
@@ -4622,7 +4622,7 @@
           <a:p>
             <a:fld id="{0185167F-B3C2-4DA8-9674-B15336757B83}" type="datetime1">
               <a:rPr lang="es-ES" smtClean="0"/>
-              <a:t>20/04/2026</a:t>
+              <a:t>27/04/2026</a:t>
             </a:fld>
             <a:endParaRPr lang="es-ES" dirty="0"/>
           </a:p>
@@ -5041,7 +5041,7 @@
           <a:p>
             <a:fld id="{1FEA0A98-1514-42DB-89DA-B5EA6B8FA61E}" type="datetime1">
               <a:rPr lang="es-ES" smtClean="0"/>
-              <a:t>20/04/2026</a:t>
+              <a:t>27/04/2026</a:t>
             </a:fld>
             <a:endParaRPr lang="es-ES" dirty="0"/>
           </a:p>
@@ -5158,7 +5158,7 @@
           <a:p>
             <a:fld id="{2D2F0422-C423-4D78-9178-62B717BC65E5}" type="datetime1">
               <a:rPr lang="es-ES" smtClean="0"/>
-              <a:t>20/04/2026</a:t>
+              <a:t>27/04/2026</a:t>
             </a:fld>
             <a:endParaRPr lang="es-ES" dirty="0"/>
           </a:p>
@@ -5253,7 +5253,7 @@
           <a:p>
             <a:fld id="{E780723B-F2CA-4EBC-A126-449EAF811C39}" type="datetime1">
               <a:rPr lang="es-ES" smtClean="0"/>
-              <a:t>20/04/2026</a:t>
+              <a:t>27/04/2026</a:t>
             </a:fld>
             <a:endParaRPr lang="es-ES" dirty="0"/>
           </a:p>
@@ -5528,7 +5528,7 @@
           <a:p>
             <a:fld id="{EC0120F4-783A-4250-877F-E0A6411B767E}" type="datetime1">
               <a:rPr lang="es-ES" smtClean="0"/>
-              <a:t>20/04/2026</a:t>
+              <a:t>27/04/2026</a:t>
             </a:fld>
             <a:endParaRPr lang="es-ES" dirty="0"/>
           </a:p>
@@ -5784,7 +5784,7 @@
           <a:p>
             <a:fld id="{AE927486-B8F2-4D10-B9C2-722D4A49DC5F}" type="datetime1">
               <a:rPr lang="es-ES" smtClean="0"/>
-              <a:t>20/04/2026</a:t>
+              <a:t>27/04/2026</a:t>
             </a:fld>
             <a:endParaRPr lang="es-ES" dirty="0"/>
           </a:p>
@@ -5995,7 +5995,7 @@
           <a:p>
             <a:fld id="{7ED72F16-78D9-4E02-8ABC-DA6468D0B2C6}" type="datetime1">
               <a:rPr lang="es-ES" smtClean="0"/>
-              <a:t>20/04/2026</a:t>
+              <a:t>27/04/2026</a:t>
             </a:fld>
             <a:endParaRPr lang="es-ES" dirty="0"/>
           </a:p>
@@ -6505,7 +6505,7 @@
           <a:p>
             <a:fld id="{37013DEC-0FEE-4FF8-9051-DE981A23AC12}" type="datetimeFigureOut">
               <a:rPr lang="es-AR" smtClean="0"/>
-              <a:t>20/4/2026</a:t>
+              <a:t>27/4/2026</a:t>
             </a:fld>
             <a:endParaRPr lang="es-AR" dirty="0"/>
           </a:p>
@@ -8465,7 +8465,7 @@
                     <a:lstStyle/>
                     <a:p>
                       <a:r>
-                        <a:rPr lang="es-ES" sz="1550" b="1" kern="1200" dirty="0">
+                        <a:rPr lang="es-ES" sz="1550" b="1" kern="1200">
                           <a:solidFill>
                             <a:schemeClr val="tx1"/>
                           </a:solidFill>
@@ -8473,30 +8473,16 @@
                           <a:ea typeface="+mn-ea"/>
                           <a:cs typeface="+mn-cs"/>
                         </a:rPr>
-                        <a:t>Caso </a:t>
+                        <a:t>Caso Nº:</a:t>
                       </a:r>
-                      <a:r>
-                        <a:rPr lang="es-ES" sz="1550" b="1" kern="1200" dirty="0" err="1">
-                          <a:solidFill>
-                            <a:schemeClr val="tx1"/>
-                          </a:solidFill>
-                          <a:latin typeface="+mn-lt"/>
-                          <a:ea typeface="+mn-ea"/>
-                          <a:cs typeface="+mn-cs"/>
-                        </a:rPr>
-                        <a:t>Nº</a:t>
-                      </a:r>
-                      <a:r>
-                        <a:rPr lang="es-ES" sz="1550" b="1" kern="1200" dirty="0">
-                          <a:solidFill>
-                            <a:schemeClr val="tx1"/>
-                          </a:solidFill>
-                          <a:latin typeface="+mn-lt"/>
-                          <a:ea typeface="+mn-ea"/>
-                          <a:cs typeface="+mn-cs"/>
-                        </a:rPr>
-                        <a:t>:</a:t>
-                      </a:r>
+                      <a:endParaRPr lang="es-ES" sz="1550" b="1" kern="1200" dirty="0">
+                        <a:solidFill>
+                          <a:schemeClr val="tx1"/>
+                        </a:solidFill>
+                        <a:latin typeface="+mn-lt"/>
+                        <a:ea typeface="+mn-ea"/>
+                        <a:cs typeface="+mn-cs"/>
+                      </a:endParaRPr>
                     </a:p>
                   </a:txBody>
                   <a:tcPr>
@@ -10356,7 +10342,7 @@
                     <a:lstStyle/>
                     <a:p>
                       <a:r>
-                        <a:rPr lang="es-ES" sz="1550" b="1" kern="1200" dirty="0">
+                        <a:rPr lang="es-ES" sz="1550" b="1" kern="1200">
                           <a:solidFill>
                             <a:schemeClr val="tx1"/>
                           </a:solidFill>
@@ -10364,18 +10350,7 @@
                           <a:ea typeface="+mn-ea"/>
                           <a:cs typeface="+mn-cs"/>
                         </a:rPr>
-                        <a:t>Caso </a:t>
-                      </a:r>
-                      <a:r>
-                        <a:rPr lang="es-ES" sz="1550" b="1" kern="1200" dirty="0" err="1">
-                          <a:solidFill>
-                            <a:schemeClr val="tx1"/>
-                          </a:solidFill>
-                          <a:latin typeface="+mn-lt"/>
-                          <a:ea typeface="+mn-ea"/>
-                          <a:cs typeface="+mn-cs"/>
-                        </a:rPr>
-                        <a:t>Nº</a:t>
+                        <a:t>Caso Nº: </a:t>
                       </a:r>
                       <a:r>
                         <a:rPr lang="es-ES" sz="1550" b="1" kern="1200" dirty="0">
@@ -10386,7 +10361,7 @@
                           <a:ea typeface="+mn-ea"/>
                           <a:cs typeface="+mn-cs"/>
                         </a:rPr>
-                        <a:t>: 4122</a:t>
+                        <a:t>4122</a:t>
                       </a:r>
                     </a:p>
                   </a:txBody>
@@ -12232,563 +12207,60 @@
           <a:chExt cx="0" cy="0"/>
         </a:xfrm>
       </p:grpSpPr>
-      <p:graphicFrame>
-        <p:nvGraphicFramePr>
-          <p:cNvPr id="17" name="3 Tabla">
+      <p:sp>
+        <p:nvSpPr>
+          <p:cNvPr id="5" name="Rectángulo 4">
             <a:extLst>
               <a:ext uri="{FF2B5EF4-FFF2-40B4-BE49-F238E27FC236}">
-                <a16:creationId xmlns:a16="http://schemas.microsoft.com/office/drawing/2014/main" id="{63E07AE5-4D0D-A736-9858-E595FD0B6861}"/>
+                <a16:creationId xmlns:a16="http://schemas.microsoft.com/office/drawing/2014/main" id="{446C82E2-438C-4F8E-B16A-A789BD314A0C}"/>
               </a:ext>
             </a:extLst>
           </p:cNvPr>
-          <p:cNvGraphicFramePr>
-            <a:graphicFrameLocks noGrp="1"/>
-          </p:cNvGraphicFramePr>
-          <p:nvPr>
-            <p:extLst>
-              <p:ext uri="{D42A27DB-BD31-4B8C-83A1-F6EECF244321}">
-                <p14:modId xmlns:p14="http://schemas.microsoft.com/office/powerpoint/2010/main" val="726290570"/>
-              </p:ext>
-            </p:extLst>
-          </p:nvPr>
-        </p:nvGraphicFramePr>
-        <p:xfrm>
-          <a:off x="0" y="5734386"/>
-          <a:ext cx="9144001" cy="1150998"/>
-        </p:xfrm>
-        <a:graphic>
-          <a:graphicData uri="http://schemas.openxmlformats.org/drawingml/2006/table">
-            <a:tbl>
-              <a:tblPr firstRow="1" bandRow="1">
-                <a:tableStyleId>{5C22544A-7EE6-4342-B048-85BDC9FD1C3A}</a:tableStyleId>
-              </a:tblPr>
-              <a:tblGrid>
-                <a:gridCol w="899592">
-                  <a:extLst>
-                    <a:ext uri="{9D8B030D-6E8A-4147-A177-3AD203B41FA5}">
-                      <a16:colId xmlns:a16="http://schemas.microsoft.com/office/drawing/2014/main" val="20000"/>
-                    </a:ext>
-                  </a:extLst>
-                </a:gridCol>
-                <a:gridCol w="1224136">
-                  <a:extLst>
-                    <a:ext uri="{9D8B030D-6E8A-4147-A177-3AD203B41FA5}">
-                      <a16:colId xmlns:a16="http://schemas.microsoft.com/office/drawing/2014/main" val="20001"/>
-                    </a:ext>
-                  </a:extLst>
-                </a:gridCol>
-                <a:gridCol w="5184576">
-                  <a:extLst>
-                    <a:ext uri="{9D8B030D-6E8A-4147-A177-3AD203B41FA5}">
-                      <a16:colId xmlns:a16="http://schemas.microsoft.com/office/drawing/2014/main" val="20002"/>
-                    </a:ext>
-                  </a:extLst>
-                </a:gridCol>
-                <a:gridCol w="1835697">
-                  <a:extLst>
-                    <a:ext uri="{9D8B030D-6E8A-4147-A177-3AD203B41FA5}">
-                      <a16:colId xmlns:a16="http://schemas.microsoft.com/office/drawing/2014/main" val="20003"/>
-                    </a:ext>
-                  </a:extLst>
-                </a:gridCol>
-              </a:tblGrid>
-              <a:tr h="395506">
-                <a:tc gridSpan="2">
-                  <a:txBody>
-                    <a:bodyPr/>
-                    <a:lstStyle/>
-                    <a:p>
-                      <a:r>
-                        <a:rPr lang="es-ES" sz="1600" dirty="0">
-                          <a:solidFill>
-                            <a:schemeClr val="tx1"/>
-                          </a:solidFill>
-                        </a:rPr>
-                        <a:t>IMAGEN</a:t>
-                      </a:r>
-                    </a:p>
-                  </a:txBody>
-                  <a:tcPr>
-                    <a:lnL w="12700" cap="flat" cmpd="sng" algn="ctr">
-                      <a:solidFill>
-                        <a:schemeClr val="tx1"/>
-                      </a:solidFill>
-                      <a:prstDash val="solid"/>
-                      <a:round/>
-                      <a:headEnd type="none" w="med" len="med"/>
-                      <a:tailEnd type="none" w="med" len="med"/>
-                    </a:lnL>
-                    <a:lnR w="12700" cap="flat" cmpd="sng" algn="ctr">
-                      <a:solidFill>
-                        <a:schemeClr val="tx1"/>
-                      </a:solidFill>
-                      <a:prstDash val="solid"/>
-                      <a:round/>
-                      <a:headEnd type="none" w="med" len="med"/>
-                      <a:tailEnd type="none" w="med" len="med"/>
-                    </a:lnR>
-                    <a:lnT w="12700" cap="flat" cmpd="sng" algn="ctr">
-                      <a:solidFill>
-                        <a:schemeClr val="tx1"/>
-                      </a:solidFill>
-                      <a:prstDash val="solid"/>
-                      <a:round/>
-                      <a:headEnd type="none" w="med" len="med"/>
-                      <a:tailEnd type="none" w="med" len="med"/>
-                    </a:lnT>
-                    <a:gradFill>
-                      <a:gsLst>
-                        <a:gs pos="0">
-                          <a:srgbClr val="8488C4"/>
-                        </a:gs>
-                        <a:gs pos="0">
-                          <a:srgbClr val="D4DEFF"/>
-                        </a:gs>
-                        <a:gs pos="0">
-                          <a:srgbClr val="D4DEFF"/>
-                        </a:gs>
-                        <a:gs pos="100000">
-                          <a:srgbClr val="96AB94"/>
-                        </a:gs>
-                      </a:gsLst>
-                      <a:lin ang="16200000" scaled="0"/>
-                    </a:gradFill>
-                  </a:tcPr>
-                </a:tc>
-                <a:tc hMerge="1">
-                  <a:txBody>
-                    <a:bodyPr/>
-                    <a:lstStyle/>
-                    <a:p>
-                      <a:endParaRPr lang="es-ES" sz="1200" dirty="0">
-                        <a:solidFill>
-                          <a:schemeClr val="tx1"/>
-                        </a:solidFill>
-                      </a:endParaRPr>
-                    </a:p>
-                  </a:txBody>
-                  <a:tcPr>
-                    <a:lnR w="12700" cap="flat" cmpd="sng" algn="ctr">
-                      <a:solidFill>
-                        <a:schemeClr val="tx1"/>
-                      </a:solidFill>
-                      <a:prstDash val="solid"/>
-                      <a:round/>
-                      <a:headEnd type="none" w="med" len="med"/>
-                      <a:tailEnd type="none" w="med" len="med"/>
-                    </a:lnR>
-                    <a:lnT w="12700" cap="flat" cmpd="sng" algn="ctr">
-                      <a:solidFill>
-                        <a:schemeClr val="tx1"/>
-                      </a:solidFill>
-                      <a:prstDash val="solid"/>
-                      <a:round/>
-                      <a:headEnd type="none" w="med" len="med"/>
-                      <a:tailEnd type="none" w="med" len="med"/>
-                    </a:lnT>
-                    <a:gradFill>
-                      <a:gsLst>
-                        <a:gs pos="0">
-                          <a:srgbClr val="8488C4"/>
-                        </a:gs>
-                        <a:gs pos="0">
-                          <a:srgbClr val="D4DEFF"/>
-                        </a:gs>
-                        <a:gs pos="0">
-                          <a:srgbClr val="D4DEFF"/>
-                        </a:gs>
-                        <a:gs pos="100000">
-                          <a:srgbClr val="96AB94"/>
-                        </a:gs>
-                      </a:gsLst>
-                      <a:lin ang="16200000" scaled="0"/>
-                    </a:gradFill>
-                  </a:tcPr>
-                </a:tc>
-                <a:tc rowSpan="3">
-                  <a:txBody>
-                    <a:bodyPr/>
-                    <a:lstStyle/>
-                    <a:p>
-                      <a:r>
-                        <a:rPr lang="es-ES" sz="1400" dirty="0">
-                          <a:solidFill>
-                            <a:schemeClr val="tx1"/>
-                          </a:solidFill>
-                        </a:rPr>
-                        <a:t>Observaciones</a:t>
-                      </a:r>
-                      <a:r>
-                        <a:rPr lang="es-ES" sz="1400" baseline="0" dirty="0">
-                          <a:solidFill>
-                            <a:schemeClr val="tx1"/>
-                          </a:solidFill>
-                        </a:rPr>
-                        <a:t> de la imagen:</a:t>
-                      </a:r>
-                    </a:p>
-                    <a:p>
-                      <a:endParaRPr lang="es-ES" sz="1400" baseline="0" dirty="0">
-                        <a:solidFill>
-                          <a:schemeClr val="tx1"/>
-                        </a:solidFill>
-                      </a:endParaRPr>
-                    </a:p>
-                  </a:txBody>
-                  <a:tcPr>
-                    <a:lnL w="12700" cap="flat" cmpd="sng" algn="ctr">
-                      <a:solidFill>
-                        <a:schemeClr val="tx1"/>
-                      </a:solidFill>
-                      <a:prstDash val="solid"/>
-                      <a:round/>
-                      <a:headEnd type="none" w="med" len="med"/>
-                      <a:tailEnd type="none" w="med" len="med"/>
-                    </a:lnL>
-                    <a:lnR w="12700" cap="flat" cmpd="sng" algn="ctr">
-                      <a:solidFill>
-                        <a:schemeClr val="bg1"/>
-                      </a:solidFill>
-                      <a:prstDash val="solid"/>
-                      <a:round/>
-                      <a:headEnd type="none" w="med" len="med"/>
-                      <a:tailEnd type="none" w="med" len="med"/>
-                    </a:lnR>
-                    <a:lnT w="12700" cap="flat" cmpd="sng" algn="ctr">
-                      <a:solidFill>
-                        <a:schemeClr val="tx1"/>
-                      </a:solidFill>
-                      <a:prstDash val="solid"/>
-                      <a:round/>
-                      <a:headEnd type="none" w="med" len="med"/>
-                      <a:tailEnd type="none" w="med" len="med"/>
-                    </a:lnT>
-                    <a:lnB w="12700" cap="flat" cmpd="sng" algn="ctr">
-                      <a:solidFill>
-                        <a:schemeClr val="tx1"/>
-                      </a:solidFill>
-                      <a:prstDash val="solid"/>
-                      <a:round/>
-                      <a:headEnd type="none" w="med" len="med"/>
-                      <a:tailEnd type="none" w="med" len="med"/>
-                    </a:lnB>
-                    <a:solidFill>
-                      <a:schemeClr val="bg1"/>
-                    </a:solidFill>
-                  </a:tcPr>
-                </a:tc>
-                <a:tc rowSpan="3">
-                  <a:txBody>
-                    <a:bodyPr/>
-                    <a:lstStyle/>
-                    <a:p>
-                      <a:endParaRPr lang="es-ES" sz="1600" dirty="0">
-                        <a:solidFill>
-                          <a:schemeClr val="tx1"/>
-                        </a:solidFill>
-                      </a:endParaRPr>
-                    </a:p>
-                  </a:txBody>
-                  <a:tcPr>
-                    <a:lnL w="12700" cap="flat" cmpd="sng" algn="ctr">
-                      <a:solidFill>
-                        <a:schemeClr val="bg1"/>
-                      </a:solidFill>
-                      <a:prstDash val="solid"/>
-                      <a:round/>
-                      <a:headEnd type="none" w="med" len="med"/>
-                      <a:tailEnd type="none" w="med" len="med"/>
-                    </a:lnL>
-                    <a:lnR w="12700" cap="flat" cmpd="sng" algn="ctr">
-                      <a:solidFill>
-                        <a:schemeClr val="tx1"/>
-                      </a:solidFill>
-                      <a:prstDash val="solid"/>
-                      <a:round/>
-                      <a:headEnd type="none" w="med" len="med"/>
-                      <a:tailEnd type="none" w="med" len="med"/>
-                    </a:lnR>
-                    <a:lnT w="12700" cap="flat" cmpd="sng" algn="ctr">
-                      <a:solidFill>
-                        <a:schemeClr val="tx1"/>
-                      </a:solidFill>
-                      <a:prstDash val="solid"/>
-                      <a:round/>
-                      <a:headEnd type="none" w="med" len="med"/>
-                      <a:tailEnd type="none" w="med" len="med"/>
-                    </a:lnT>
-                    <a:lnB w="12700" cap="flat" cmpd="sng" algn="ctr">
-                      <a:solidFill>
-                        <a:schemeClr val="tx1"/>
-                      </a:solidFill>
-                      <a:prstDash val="solid"/>
-                      <a:round/>
-                      <a:headEnd type="none" w="med" len="med"/>
-                      <a:tailEnd type="none" w="med" len="med"/>
-                    </a:lnB>
-                    <a:solidFill>
-                      <a:schemeClr val="bg1"/>
-                    </a:solidFill>
-                  </a:tcPr>
-                </a:tc>
-                <a:extLst>
-                  <a:ext uri="{0D108BD9-81ED-4DB2-BD59-A6C34878D82A}">
-                    <a16:rowId xmlns:a16="http://schemas.microsoft.com/office/drawing/2014/main" val="10000"/>
-                  </a:ext>
-                </a:extLst>
-              </a:tr>
-              <a:tr h="323596">
-                <a:tc>
-                  <a:txBody>
-                    <a:bodyPr/>
-                    <a:lstStyle/>
-                    <a:p>
-                      <a:r>
-                        <a:rPr lang="es-ES" sz="1200" dirty="0">
-                          <a:solidFill>
-                            <a:schemeClr val="tx1"/>
-                          </a:solidFill>
-                        </a:rPr>
-                        <a:t>Hora:</a:t>
-                      </a:r>
-                    </a:p>
-                  </a:txBody>
-                  <a:tcPr>
-                    <a:lnL w="12700" cap="flat" cmpd="sng" algn="ctr">
-                      <a:solidFill>
-                        <a:schemeClr val="tx1"/>
-                      </a:solidFill>
-                      <a:prstDash val="solid"/>
-                      <a:round/>
-                      <a:headEnd type="none" w="med" len="med"/>
-                      <a:tailEnd type="none" w="med" len="med"/>
-                    </a:lnL>
-                  </a:tcPr>
-                </a:tc>
-                <a:tc>
-                  <a:txBody>
-                    <a:bodyPr/>
-                    <a:lstStyle/>
-                    <a:p>
-                      <a:pPr marL="0" marR="0" lvl="0" indent="0" algn="l" defTabSz="914400" rtl="0" eaLnBrk="1" fontAlgn="auto" latinLnBrk="0" hangingPunct="1">
-                        <a:lnSpc>
-                          <a:spcPct val="100000"/>
-                        </a:lnSpc>
-                        <a:spcBef>
-                          <a:spcPts val="0"/>
-                        </a:spcBef>
-                        <a:spcAft>
-                          <a:spcPts val="0"/>
-                        </a:spcAft>
-                        <a:buClrTx/>
-                        <a:buSzTx/>
-                        <a:buFontTx/>
-                        <a:buNone/>
-                        <a:tabLst/>
-                        <a:defRPr/>
-                      </a:pPr>
-                      <a:r>
-                        <a:rPr lang="es-ES" sz="1200" dirty="0"/>
-                        <a:t>[hora]</a:t>
-                      </a:r>
-                      <a:endParaRPr lang="es-AR" sz="1200" dirty="0"/>
-                    </a:p>
-                  </a:txBody>
-                  <a:tcPr>
-                    <a:lnR w="12700" cap="flat" cmpd="sng" algn="ctr">
-                      <a:solidFill>
-                        <a:schemeClr val="tx1"/>
-                      </a:solidFill>
-                      <a:prstDash val="solid"/>
-                      <a:round/>
-                      <a:headEnd type="none" w="med" len="med"/>
-                      <a:tailEnd type="none" w="med" len="med"/>
-                    </a:lnR>
-                  </a:tcPr>
-                </a:tc>
-                <a:tc vMerge="1">
-                  <a:txBody>
-                    <a:bodyPr/>
-                    <a:lstStyle/>
-                    <a:p>
-                      <a:endParaRPr lang="es-ES" sz="1200" dirty="0">
-                        <a:solidFill>
-                          <a:schemeClr val="tx1"/>
-                        </a:solidFill>
-                      </a:endParaRPr>
-                    </a:p>
-                  </a:txBody>
-                  <a:tcPr>
-                    <a:lnR w="12700" cap="flat" cmpd="sng" algn="ctr">
-                      <a:solidFill>
-                        <a:schemeClr val="tx1"/>
-                      </a:solidFill>
-                      <a:prstDash val="solid"/>
-                      <a:round/>
-                      <a:headEnd type="none" w="med" len="med"/>
-                      <a:tailEnd type="none" w="med" len="med"/>
-                    </a:lnR>
-                  </a:tcPr>
-                </a:tc>
-                <a:tc vMerge="1">
-                  <a:txBody>
-                    <a:bodyPr/>
-                    <a:lstStyle/>
-                    <a:p>
-                      <a:endParaRPr lang="es-ES"/>
-                    </a:p>
-                  </a:txBody>
-                  <a:tcPr/>
-                </a:tc>
-                <a:extLst>
-                  <a:ext uri="{0D108BD9-81ED-4DB2-BD59-A6C34878D82A}">
-                    <a16:rowId xmlns:a16="http://schemas.microsoft.com/office/drawing/2014/main" val="10001"/>
-                  </a:ext>
-                </a:extLst>
-              </a:tr>
-              <a:tr h="431896">
-                <a:tc>
-                  <a:txBody>
-                    <a:bodyPr/>
-                    <a:lstStyle/>
-                    <a:p>
-                      <a:r>
-                        <a:rPr lang="es-ES" sz="1200" dirty="0">
-                          <a:solidFill>
-                            <a:schemeClr val="tx1"/>
-                          </a:solidFill>
-                        </a:rPr>
-                        <a:t>Ubicación:</a:t>
-                      </a:r>
-                    </a:p>
-                  </a:txBody>
-                  <a:tcPr>
-                    <a:lnL w="12700" cap="flat" cmpd="sng" algn="ctr">
-                      <a:solidFill>
-                        <a:schemeClr val="tx1"/>
-                      </a:solidFill>
-                      <a:prstDash val="solid"/>
-                      <a:round/>
-                      <a:headEnd type="none" w="med" len="med"/>
-                      <a:tailEnd type="none" w="med" len="med"/>
-                    </a:lnL>
-                    <a:lnB w="12700" cap="flat" cmpd="sng" algn="ctr">
-                      <a:solidFill>
-                        <a:schemeClr val="tx1"/>
-                      </a:solidFill>
-                      <a:prstDash val="solid"/>
-                      <a:round/>
-                      <a:headEnd type="none" w="med" len="med"/>
-                      <a:tailEnd type="none" w="med" len="med"/>
-                    </a:lnB>
-                  </a:tcPr>
-                </a:tc>
-                <a:tc>
-                  <a:txBody>
-                    <a:bodyPr/>
-                    <a:lstStyle/>
-                    <a:p>
-                      <a:pPr marL="0" marR="0" lvl="0" indent="0" algn="l" defTabSz="914400" rtl="0" eaLnBrk="1" fontAlgn="auto" latinLnBrk="0" hangingPunct="1">
-                        <a:lnSpc>
-                          <a:spcPct val="100000"/>
-                        </a:lnSpc>
-                        <a:spcBef>
-                          <a:spcPts val="0"/>
-                        </a:spcBef>
-                        <a:spcAft>
-                          <a:spcPts val="0"/>
-                        </a:spcAft>
-                        <a:buClrTx/>
-                        <a:buSzTx/>
-                        <a:buFontTx/>
-                        <a:buNone/>
-                        <a:tabLst/>
-                        <a:defRPr/>
-                      </a:pPr>
-                      <a:r>
-                        <a:rPr lang="es-ES" sz="1100" b="0" baseline="0" dirty="0">
-                          <a:solidFill>
-                            <a:schemeClr val="tx1"/>
-                          </a:solidFill>
-                        </a:rPr>
-                        <a:t>[ubicación]</a:t>
-                      </a:r>
-                    </a:p>
-                  </a:txBody>
-                  <a:tcPr>
-                    <a:lnR w="12700" cap="flat" cmpd="sng" algn="ctr">
-                      <a:solidFill>
-                        <a:schemeClr val="tx1"/>
-                      </a:solidFill>
-                      <a:prstDash val="solid"/>
-                      <a:round/>
-                      <a:headEnd type="none" w="med" len="med"/>
-                      <a:tailEnd type="none" w="med" len="med"/>
-                    </a:lnR>
-                    <a:lnB w="12700" cap="flat" cmpd="sng" algn="ctr">
-                      <a:solidFill>
-                        <a:schemeClr val="tx1"/>
-                      </a:solidFill>
-                      <a:prstDash val="solid"/>
-                      <a:round/>
-                      <a:headEnd type="none" w="med" len="med"/>
-                      <a:tailEnd type="none" w="med" len="med"/>
-                    </a:lnB>
-                  </a:tcPr>
-                </a:tc>
-                <a:tc vMerge="1">
-                  <a:txBody>
-                    <a:bodyPr/>
-                    <a:lstStyle/>
-                    <a:p>
-                      <a:endParaRPr lang="es-ES" sz="1200" dirty="0">
-                        <a:solidFill>
-                          <a:schemeClr val="tx1"/>
-                        </a:solidFill>
-                      </a:endParaRPr>
-                    </a:p>
-                  </a:txBody>
-                  <a:tcPr>
-                    <a:lnR w="12700" cap="flat" cmpd="sng" algn="ctr">
-                      <a:solidFill>
-                        <a:schemeClr val="tx1"/>
-                      </a:solidFill>
-                      <a:prstDash val="solid"/>
-                      <a:round/>
-                      <a:headEnd type="none" w="med" len="med"/>
-                      <a:tailEnd type="none" w="med" len="med"/>
-                    </a:lnR>
-                    <a:lnB w="12700" cap="flat" cmpd="sng" algn="ctr">
-                      <a:solidFill>
-                        <a:schemeClr val="tx1"/>
-                      </a:solidFill>
-                      <a:prstDash val="solid"/>
-                      <a:round/>
-                      <a:headEnd type="none" w="med" len="med"/>
-                      <a:tailEnd type="none" w="med" len="med"/>
-                    </a:lnB>
-                  </a:tcPr>
-                </a:tc>
-                <a:tc vMerge="1">
-                  <a:txBody>
-                    <a:bodyPr/>
-                    <a:lstStyle/>
-                    <a:p>
-                      <a:endParaRPr lang="es-ES"/>
-                    </a:p>
-                  </a:txBody>
-                  <a:tcPr/>
-                </a:tc>
-                <a:extLst>
-                  <a:ext uri="{0D108BD9-81ED-4DB2-BD59-A6C34878D82A}">
-                    <a16:rowId xmlns:a16="http://schemas.microsoft.com/office/drawing/2014/main" val="10002"/>
-                  </a:ext>
-                </a:extLst>
-              </a:tr>
-            </a:tbl>
-          </a:graphicData>
-        </a:graphic>
-      </p:graphicFrame>
+          <p:cNvSpPr/>
+          <p:nvPr/>
+        </p:nvSpPr>
+        <p:spPr>
+          <a:xfrm>
+            <a:off x="0" y="5714493"/>
+            <a:ext cx="9144000" cy="1150998"/>
+          </a:xfrm>
+          <a:prstGeom prst="rect">
+            <a:avLst/>
+          </a:prstGeom>
+          <a:solidFill>
+            <a:schemeClr val="bg1"/>
+          </a:solidFill>
+          <a:ln w="15875">
+            <a:solidFill>
+              <a:schemeClr val="tx1"/>
+            </a:solidFill>
+          </a:ln>
+        </p:spPr>
+        <p:style>
+          <a:lnRef idx="2">
+            <a:schemeClr val="accent1">
+              <a:shade val="50000"/>
+            </a:schemeClr>
+          </a:lnRef>
+          <a:fillRef idx="1">
+            <a:schemeClr val="accent1"/>
+          </a:fillRef>
+          <a:effectRef idx="0">
+            <a:schemeClr val="accent1"/>
+          </a:effectRef>
+          <a:fontRef idx="minor">
+            <a:schemeClr val="lt1"/>
+          </a:fontRef>
+        </p:style>
+        <p:txBody>
+          <a:bodyPr rtlCol="0" anchor="ctr"/>
+          <a:lstStyle/>
+          <a:p>
+            <a:pPr algn="ctr"/>
+            <a:endParaRPr lang="es-AR"/>
+          </a:p>
+        </p:txBody>
+      </p:sp>
       <p:sp>
         <p:nvSpPr>
           <p:cNvPr id="2" name="1 Marcador de número de diapositiva">
@@ -12807,7 +12279,7 @@
         </p:nvSpPr>
         <p:spPr>
           <a:xfrm>
-            <a:off x="8810128" y="6669360"/>
+            <a:off x="8810128" y="6597352"/>
             <a:ext cx="298376" cy="268139"/>
           </a:xfrm>
         </p:spPr>
@@ -12975,7 +12447,7 @@
                     <a:lstStyle/>
                     <a:p>
                       <a:r>
-                        <a:rPr lang="es-ES" sz="1550" b="1" kern="1200" dirty="0">
+                        <a:rPr lang="es-ES" sz="1550" b="1" kern="1200">
                           <a:solidFill>
                             <a:schemeClr val="tx1"/>
                           </a:solidFill>
@@ -12983,30 +12455,16 @@
                           <a:ea typeface="+mn-ea"/>
                           <a:cs typeface="+mn-cs"/>
                         </a:rPr>
-                        <a:t>Caso </a:t>
+                        <a:t>Caso Nº: </a:t>
                       </a:r>
-                      <a:r>
-                        <a:rPr lang="es-ES" sz="1550" b="1" kern="1200" dirty="0" err="1">
-                          <a:solidFill>
-                            <a:schemeClr val="tx1"/>
-                          </a:solidFill>
-                          <a:latin typeface="+mn-lt"/>
-                          <a:ea typeface="+mn-ea"/>
-                          <a:cs typeface="+mn-cs"/>
-                        </a:rPr>
-                        <a:t>Nº</a:t>
-                      </a:r>
-                      <a:r>
-                        <a:rPr lang="es-ES" sz="1550" b="1" kern="1200" dirty="0">
-                          <a:solidFill>
-                            <a:schemeClr val="tx1"/>
-                          </a:solidFill>
-                          <a:latin typeface="+mn-lt"/>
-                          <a:ea typeface="+mn-ea"/>
-                          <a:cs typeface="+mn-cs"/>
-                        </a:rPr>
-                        <a:t>: </a:t>
-                      </a:r>
+                      <a:endParaRPr lang="es-ES" sz="1550" b="1" kern="1200" dirty="0">
+                        <a:solidFill>
+                          <a:schemeClr val="tx1"/>
+                        </a:solidFill>
+                        <a:latin typeface="+mn-lt"/>
+                        <a:ea typeface="+mn-ea"/>
+                        <a:cs typeface="+mn-cs"/>
+                      </a:endParaRPr>
                     </a:p>
                   </a:txBody>
                   <a:tcPr>
@@ -13314,6 +12772,458 @@
           </a:graphicData>
         </a:graphic>
       </p:graphicFrame>
+      <p:pic>
+        <p:nvPicPr>
+          <p:cNvPr id="7" name="Imagen 6">
+            <a:hlinkClick r:id="rId3" action="ppaction://hlinkfile"/>
+            <a:extLst>
+              <a:ext uri="{FF2B5EF4-FFF2-40B4-BE49-F238E27FC236}">
+                <a16:creationId xmlns:a16="http://schemas.microsoft.com/office/drawing/2014/main" id="{B4CD1AB4-1724-44B0-91EC-03F9CBE78B62}"/>
+              </a:ext>
+            </a:extLst>
+          </p:cNvPr>
+          <p:cNvPicPr>
+            <a:picLocks noChangeAspect="1"/>
+          </p:cNvPicPr>
+          <p:nvPr/>
+        </p:nvPicPr>
+        <p:blipFill>
+          <a:blip r:embed="rId4" cstate="print">
+            <a:extLst>
+              <a:ext uri="{28A0092B-C50C-407E-A947-70E740481C1C}">
+                <a14:useLocalDpi xmlns:a14="http://schemas.microsoft.com/office/drawing/2010/main" val="0"/>
+              </a:ext>
+            </a:extLst>
+          </a:blip>
+          <a:stretch>
+            <a:fillRect/>
+          </a:stretch>
+        </p:blipFill>
+        <p:spPr>
+          <a:xfrm>
+            <a:off x="8327925" y="5005112"/>
+            <a:ext cx="708571" cy="656136"/>
+          </a:xfrm>
+          <a:prstGeom prst="rect">
+            <a:avLst/>
+          </a:prstGeom>
+          <a:solidFill>
+            <a:schemeClr val="bg1">
+              <a:alpha val="50000"/>
+            </a:schemeClr>
+          </a:solidFill>
+        </p:spPr>
+      </p:pic>
+      <p:graphicFrame>
+        <p:nvGraphicFramePr>
+          <p:cNvPr id="9" name="3 Tabla">
+            <a:extLst>
+              <a:ext uri="{FF2B5EF4-FFF2-40B4-BE49-F238E27FC236}">
+                <a16:creationId xmlns:a16="http://schemas.microsoft.com/office/drawing/2014/main" id="{EA439D2E-488B-4C9D-AAA7-63D61F6D4E06}"/>
+              </a:ext>
+            </a:extLst>
+          </p:cNvPr>
+          <p:cNvGraphicFramePr>
+            <a:graphicFrameLocks noGrp="1"/>
+          </p:cNvGraphicFramePr>
+          <p:nvPr>
+            <p:extLst>
+              <p:ext uri="{D42A27DB-BD31-4B8C-83A1-F6EECF244321}">
+                <p14:modId xmlns:p14="http://schemas.microsoft.com/office/powerpoint/2010/main" val="3779881686"/>
+              </p:ext>
+            </p:extLst>
+          </p:nvPr>
+        </p:nvGraphicFramePr>
+        <p:xfrm>
+          <a:off x="0" y="5714493"/>
+          <a:ext cx="2115484" cy="1150998"/>
+        </p:xfrm>
+        <a:graphic>
+          <a:graphicData uri="http://schemas.openxmlformats.org/drawingml/2006/table">
+            <a:tbl>
+              <a:tblPr firstRow="1" bandRow="1">
+                <a:tableStyleId>{5C22544A-7EE6-4342-B048-85BDC9FD1C3A}</a:tableStyleId>
+              </a:tblPr>
+              <a:tblGrid>
+                <a:gridCol w="896100">
+                  <a:extLst>
+                    <a:ext uri="{9D8B030D-6E8A-4147-A177-3AD203B41FA5}">
+                      <a16:colId xmlns:a16="http://schemas.microsoft.com/office/drawing/2014/main" val="20000"/>
+                    </a:ext>
+                  </a:extLst>
+                </a:gridCol>
+                <a:gridCol w="1219384">
+                  <a:extLst>
+                    <a:ext uri="{9D8B030D-6E8A-4147-A177-3AD203B41FA5}">
+                      <a16:colId xmlns:a16="http://schemas.microsoft.com/office/drawing/2014/main" val="20001"/>
+                    </a:ext>
+                  </a:extLst>
+                </a:gridCol>
+              </a:tblGrid>
+              <a:tr h="395506">
+                <a:tc gridSpan="2">
+                  <a:txBody>
+                    <a:bodyPr/>
+                    <a:lstStyle/>
+                    <a:p>
+                      <a:r>
+                        <a:rPr lang="es-ES" sz="1600" dirty="0">
+                          <a:solidFill>
+                            <a:schemeClr val="tx1"/>
+                          </a:solidFill>
+                        </a:rPr>
+                        <a:t>IMAGEN</a:t>
+                      </a:r>
+                    </a:p>
+                  </a:txBody>
+                  <a:tcPr>
+                    <a:lnL w="12700" cap="flat" cmpd="sng" algn="ctr">
+                      <a:solidFill>
+                        <a:schemeClr val="tx1"/>
+                      </a:solidFill>
+                      <a:prstDash val="solid"/>
+                      <a:round/>
+                      <a:headEnd type="none" w="med" len="med"/>
+                      <a:tailEnd type="none" w="med" len="med"/>
+                    </a:lnL>
+                    <a:lnR w="12700" cap="flat" cmpd="sng" algn="ctr">
+                      <a:solidFill>
+                        <a:schemeClr val="tx1"/>
+                      </a:solidFill>
+                      <a:prstDash val="solid"/>
+                      <a:round/>
+                      <a:headEnd type="none" w="med" len="med"/>
+                      <a:tailEnd type="none" w="med" len="med"/>
+                    </a:lnR>
+                    <a:lnT w="12700" cap="flat" cmpd="sng" algn="ctr">
+                      <a:solidFill>
+                        <a:schemeClr val="tx1"/>
+                      </a:solidFill>
+                      <a:prstDash val="solid"/>
+                      <a:round/>
+                      <a:headEnd type="none" w="med" len="med"/>
+                      <a:tailEnd type="none" w="med" len="med"/>
+                    </a:lnT>
+                    <a:gradFill>
+                      <a:gsLst>
+                        <a:gs pos="0">
+                          <a:srgbClr val="8488C4"/>
+                        </a:gs>
+                        <a:gs pos="0">
+                          <a:srgbClr val="D4DEFF"/>
+                        </a:gs>
+                        <a:gs pos="0">
+                          <a:srgbClr val="D4DEFF"/>
+                        </a:gs>
+                        <a:gs pos="100000">
+                          <a:srgbClr val="96AB94"/>
+                        </a:gs>
+                      </a:gsLst>
+                      <a:lin ang="16200000" scaled="0"/>
+                    </a:gradFill>
+                  </a:tcPr>
+                </a:tc>
+                <a:tc hMerge="1">
+                  <a:txBody>
+                    <a:bodyPr/>
+                    <a:lstStyle/>
+                    <a:p>
+                      <a:endParaRPr lang="es-ES" sz="1200" dirty="0">
+                        <a:solidFill>
+                          <a:schemeClr val="tx1"/>
+                        </a:solidFill>
+                      </a:endParaRPr>
+                    </a:p>
+                  </a:txBody>
+                  <a:tcPr>
+                    <a:lnR w="12700" cap="flat" cmpd="sng" algn="ctr">
+                      <a:solidFill>
+                        <a:schemeClr val="tx1"/>
+                      </a:solidFill>
+                      <a:prstDash val="solid"/>
+                      <a:round/>
+                      <a:headEnd type="none" w="med" len="med"/>
+                      <a:tailEnd type="none" w="med" len="med"/>
+                    </a:lnR>
+                    <a:lnT w="12700" cap="flat" cmpd="sng" algn="ctr">
+                      <a:solidFill>
+                        <a:schemeClr val="tx1"/>
+                      </a:solidFill>
+                      <a:prstDash val="solid"/>
+                      <a:round/>
+                      <a:headEnd type="none" w="med" len="med"/>
+                      <a:tailEnd type="none" w="med" len="med"/>
+                    </a:lnT>
+                    <a:gradFill>
+                      <a:gsLst>
+                        <a:gs pos="0">
+                          <a:srgbClr val="8488C4"/>
+                        </a:gs>
+                        <a:gs pos="0">
+                          <a:srgbClr val="D4DEFF"/>
+                        </a:gs>
+                        <a:gs pos="0">
+                          <a:srgbClr val="D4DEFF"/>
+                        </a:gs>
+                        <a:gs pos="100000">
+                          <a:srgbClr val="96AB94"/>
+                        </a:gs>
+                      </a:gsLst>
+                      <a:lin ang="16200000" scaled="0"/>
+                    </a:gradFill>
+                  </a:tcPr>
+                </a:tc>
+                <a:extLst>
+                  <a:ext uri="{0D108BD9-81ED-4DB2-BD59-A6C34878D82A}">
+                    <a16:rowId xmlns:a16="http://schemas.microsoft.com/office/drawing/2014/main" val="10000"/>
+                  </a:ext>
+                </a:extLst>
+              </a:tr>
+              <a:tr h="323596">
+                <a:tc>
+                  <a:txBody>
+                    <a:bodyPr/>
+                    <a:lstStyle/>
+                    <a:p>
+                      <a:r>
+                        <a:rPr lang="es-ES" sz="1200" dirty="0">
+                          <a:solidFill>
+                            <a:schemeClr val="tx1"/>
+                          </a:solidFill>
+                        </a:rPr>
+                        <a:t>Hora:</a:t>
+                      </a:r>
+                    </a:p>
+                  </a:txBody>
+                  <a:tcPr>
+                    <a:lnL w="12700" cap="flat" cmpd="sng" algn="ctr">
+                      <a:solidFill>
+                        <a:schemeClr val="tx1"/>
+                      </a:solidFill>
+                      <a:prstDash val="solid"/>
+                      <a:round/>
+                      <a:headEnd type="none" w="med" len="med"/>
+                      <a:tailEnd type="none" w="med" len="med"/>
+                    </a:lnL>
+                  </a:tcPr>
+                </a:tc>
+                <a:tc>
+                  <a:txBody>
+                    <a:bodyPr/>
+                    <a:lstStyle/>
+                    <a:p>
+                      <a:pPr marL="0" marR="0" lvl="0" indent="0" algn="l" defTabSz="914400" rtl="0" eaLnBrk="1" fontAlgn="auto" latinLnBrk="0" hangingPunct="1">
+                        <a:lnSpc>
+                          <a:spcPct val="100000"/>
+                        </a:lnSpc>
+                        <a:spcBef>
+                          <a:spcPts val="0"/>
+                        </a:spcBef>
+                        <a:spcAft>
+                          <a:spcPts val="0"/>
+                        </a:spcAft>
+                        <a:buClrTx/>
+                        <a:buSzTx/>
+                        <a:buFontTx/>
+                        <a:buNone/>
+                        <a:tabLst/>
+                        <a:defRPr/>
+                      </a:pPr>
+                      <a:r>
+                        <a:rPr lang="es-AR" sz="1200" dirty="0"/>
+                        <a:t>[hora]</a:t>
+                      </a:r>
+                    </a:p>
+                  </a:txBody>
+                  <a:tcPr>
+                    <a:lnR w="12700" cap="flat" cmpd="sng" algn="ctr">
+                      <a:solidFill>
+                        <a:schemeClr val="tx1"/>
+                      </a:solidFill>
+                      <a:prstDash val="solid"/>
+                      <a:round/>
+                      <a:headEnd type="none" w="med" len="med"/>
+                      <a:tailEnd type="none" w="med" len="med"/>
+                    </a:lnR>
+                  </a:tcPr>
+                </a:tc>
+                <a:extLst>
+                  <a:ext uri="{0D108BD9-81ED-4DB2-BD59-A6C34878D82A}">
+                    <a16:rowId xmlns:a16="http://schemas.microsoft.com/office/drawing/2014/main" val="10001"/>
+                  </a:ext>
+                </a:extLst>
+              </a:tr>
+              <a:tr h="431896">
+                <a:tc>
+                  <a:txBody>
+                    <a:bodyPr/>
+                    <a:lstStyle/>
+                    <a:p>
+                      <a:r>
+                        <a:rPr lang="es-ES" sz="1200" dirty="0">
+                          <a:solidFill>
+                            <a:schemeClr val="tx1"/>
+                          </a:solidFill>
+                        </a:rPr>
+                        <a:t>Ubicación:</a:t>
+                      </a:r>
+                    </a:p>
+                  </a:txBody>
+                  <a:tcPr>
+                    <a:lnL w="12700" cap="flat" cmpd="sng" algn="ctr">
+                      <a:solidFill>
+                        <a:schemeClr val="tx1"/>
+                      </a:solidFill>
+                      <a:prstDash val="solid"/>
+                      <a:round/>
+                      <a:headEnd type="none" w="med" len="med"/>
+                      <a:tailEnd type="none" w="med" len="med"/>
+                    </a:lnL>
+                    <a:lnB w="12700" cap="flat" cmpd="sng" algn="ctr">
+                      <a:solidFill>
+                        <a:schemeClr val="tx1"/>
+                      </a:solidFill>
+                      <a:prstDash val="solid"/>
+                      <a:round/>
+                      <a:headEnd type="none" w="med" len="med"/>
+                      <a:tailEnd type="none" w="med" len="med"/>
+                    </a:lnB>
+                  </a:tcPr>
+                </a:tc>
+                <a:tc>
+                  <a:txBody>
+                    <a:bodyPr/>
+                    <a:lstStyle/>
+                    <a:p>
+                      <a:pPr marL="0" marR="0" indent="0" algn="l" defTabSz="914400" rtl="0" eaLnBrk="1" fontAlgn="auto" latinLnBrk="0" hangingPunct="1">
+                        <a:lnSpc>
+                          <a:spcPct val="100000"/>
+                        </a:lnSpc>
+                        <a:spcBef>
+                          <a:spcPts val="0"/>
+                        </a:spcBef>
+                        <a:spcAft>
+                          <a:spcPts val="0"/>
+                        </a:spcAft>
+                        <a:buClrTx/>
+                        <a:buSzTx/>
+                        <a:buFontTx/>
+                        <a:buNone/>
+                        <a:tabLst/>
+                        <a:defRPr/>
+                      </a:pPr>
+                      <a:r>
+                        <a:rPr lang="es-ES" sz="1100" b="0" baseline="0" dirty="0">
+                          <a:solidFill>
+                            <a:schemeClr val="tx1"/>
+                          </a:solidFill>
+                        </a:rPr>
+                        <a:t>[</a:t>
+                      </a:r>
+                      <a:r>
+                        <a:rPr lang="es-ES" sz="1100" b="0" baseline="0" dirty="0" err="1">
+                          <a:solidFill>
+                            <a:schemeClr val="tx1"/>
+                          </a:solidFill>
+                        </a:rPr>
+                        <a:t>ubicacion</a:t>
+                      </a:r>
+                      <a:r>
+                        <a:rPr lang="es-ES" sz="1100" b="0" baseline="0" dirty="0">
+                          <a:solidFill>
+                            <a:schemeClr val="tx1"/>
+                          </a:solidFill>
+                        </a:rPr>
+                        <a:t>]</a:t>
+                      </a:r>
+                    </a:p>
+                  </a:txBody>
+                  <a:tcPr>
+                    <a:lnR w="12700" cap="flat" cmpd="sng" algn="ctr">
+                      <a:solidFill>
+                        <a:schemeClr val="tx1"/>
+                      </a:solidFill>
+                      <a:prstDash val="solid"/>
+                      <a:round/>
+                      <a:headEnd type="none" w="med" len="med"/>
+                      <a:tailEnd type="none" w="med" len="med"/>
+                    </a:lnR>
+                    <a:lnB w="12700" cap="flat" cmpd="sng" algn="ctr">
+                      <a:solidFill>
+                        <a:schemeClr val="tx1"/>
+                      </a:solidFill>
+                      <a:prstDash val="solid"/>
+                      <a:round/>
+                      <a:headEnd type="none" w="med" len="med"/>
+                      <a:tailEnd type="none" w="med" len="med"/>
+                    </a:lnB>
+                  </a:tcPr>
+                </a:tc>
+                <a:extLst>
+                  <a:ext uri="{0D108BD9-81ED-4DB2-BD59-A6C34878D82A}">
+                    <a16:rowId xmlns:a16="http://schemas.microsoft.com/office/drawing/2014/main" val="10002"/>
+                  </a:ext>
+                </a:extLst>
+              </a:tr>
+            </a:tbl>
+          </a:graphicData>
+        </a:graphic>
+      </p:graphicFrame>
+      <p:sp>
+        <p:nvSpPr>
+          <p:cNvPr id="11" name="CuadroTexto 10">
+            <a:extLst>
+              <a:ext uri="{FF2B5EF4-FFF2-40B4-BE49-F238E27FC236}">
+                <a16:creationId xmlns:a16="http://schemas.microsoft.com/office/drawing/2014/main" id="{20166999-8B36-443F-9FD6-EDAB0927134B}"/>
+              </a:ext>
+            </a:extLst>
+          </p:cNvPr>
+          <p:cNvSpPr txBox="1"/>
+          <p:nvPr/>
+        </p:nvSpPr>
+        <p:spPr>
+          <a:xfrm>
+            <a:off x="2123728" y="5733256"/>
+            <a:ext cx="5472608" cy="307777"/>
+          </a:xfrm>
+          <a:prstGeom prst="rect">
+            <a:avLst/>
+          </a:prstGeom>
+          <a:noFill/>
+        </p:spPr>
+        <p:txBody>
+          <a:bodyPr wrap="square" rtlCol="0">
+            <a:spAutoFit/>
+          </a:bodyPr>
+          <a:lstStyle/>
+          <a:p>
+            <a:r>
+              <a:rPr lang="es-ES" sz="1400" b="0" baseline="0" dirty="0">
+                <a:solidFill>
+                  <a:schemeClr val="tx1"/>
+                </a:solidFill>
+              </a:rPr>
+              <a:t>[</a:t>
+            </a:r>
+            <a:r>
+              <a:rPr lang="es-ES" sz="1400" b="0" baseline="0" dirty="0" err="1">
+                <a:solidFill>
+                  <a:schemeClr val="tx1"/>
+                </a:solidFill>
+              </a:rPr>
+              <a:t>observacion</a:t>
+            </a:r>
+            <a:r>
+              <a:rPr lang="es-ES" sz="1400" b="0" baseline="0" dirty="0">
+                <a:solidFill>
+                  <a:schemeClr val="tx1"/>
+                </a:solidFill>
+              </a:rPr>
+              <a:t>]</a:t>
+            </a:r>
+          </a:p>
+        </p:txBody>
+      </p:sp>
     </p:spTree>
     <p:extLst>
       <p:ext uri="{BB962C8B-B14F-4D97-AF65-F5344CB8AC3E}">

</xml_diff>

<commit_message>
feature: logre seleccionar un directorio y cargar los videos en la tabla
</commit_message>
<xml_diff>
--- a/templates/template.pptx
+++ b/templates/template.pptx
@@ -276,7 +276,7 @@
           <a:p>
             <a:fld id="{9C0EC74A-97EC-4D13-AC48-B7F39774675E}" type="datetimeFigureOut">
               <a:rPr lang="es-ES" smtClean="0"/>
-              <a:t>03/06/2026</a:t>
+              <a:t>22/06/2026</a:t>
             </a:fld>
             <a:endParaRPr lang="es-ES" dirty="0"/>
           </a:p>
@@ -442,7 +442,7 @@
           <a:p>
             <a:fld id="{10088373-C7C4-43EF-8EE4-15B3BD82BE94}" type="datetimeFigureOut">
               <a:rPr lang="es-ES" smtClean="0"/>
-              <a:t>03/06/2026</a:t>
+              <a:t>22/06/2026</a:t>
             </a:fld>
             <a:endParaRPr lang="es-ES" dirty="0"/>
           </a:p>
@@ -1542,7 +1542,7 @@
           <a:p>
             <a:fld id="{D184388A-CDDF-4860-AF28-3D21AC68C4D5}" type="datetime1">
               <a:rPr lang="es-ES" smtClean="0"/>
-              <a:t>03/06/2026</a:t>
+              <a:t>22/06/2026</a:t>
             </a:fld>
             <a:endParaRPr lang="es-ES" dirty="0"/>
           </a:p>
@@ -1710,7 +1710,7 @@
           <a:p>
             <a:fld id="{AF50F199-EC87-494F-81A5-8B1F1A78F27C}" type="datetime1">
               <a:rPr lang="es-ES" smtClean="0"/>
-              <a:t>03/06/2026</a:t>
+              <a:t>22/06/2026</a:t>
             </a:fld>
             <a:endParaRPr lang="es-ES" dirty="0"/>
           </a:p>
@@ -1902,7 +1902,7 @@
           <a:p>
             <a:fld id="{37013DEC-0FEE-4FF8-9051-DE981A23AC12}" type="datetimeFigureOut">
               <a:rPr lang="es-AR" smtClean="0"/>
-              <a:t>3/6/2026</a:t>
+              <a:t>22/6/2026</a:t>
             </a:fld>
             <a:endParaRPr lang="es-AR" dirty="0"/>
           </a:p>
@@ -2072,7 +2072,7 @@
           <a:p>
             <a:fld id="{37013DEC-0FEE-4FF8-9051-DE981A23AC12}" type="datetimeFigureOut">
               <a:rPr lang="es-AR" smtClean="0"/>
-              <a:t>3/6/2026</a:t>
+              <a:t>22/6/2026</a:t>
             </a:fld>
             <a:endParaRPr lang="es-AR" dirty="0"/>
           </a:p>
@@ -2318,7 +2318,7 @@
           <a:p>
             <a:fld id="{37013DEC-0FEE-4FF8-9051-DE981A23AC12}" type="datetimeFigureOut">
               <a:rPr lang="es-AR" smtClean="0"/>
-              <a:t>3/6/2026</a:t>
+              <a:t>22/6/2026</a:t>
             </a:fld>
             <a:endParaRPr lang="es-AR" dirty="0"/>
           </a:p>
@@ -2550,7 +2550,7 @@
           <a:p>
             <a:fld id="{37013DEC-0FEE-4FF8-9051-DE981A23AC12}" type="datetimeFigureOut">
               <a:rPr lang="es-AR" smtClean="0"/>
-              <a:t>3/6/2026</a:t>
+              <a:t>22/6/2026</a:t>
             </a:fld>
             <a:endParaRPr lang="es-AR" dirty="0"/>
           </a:p>
@@ -2917,7 +2917,7 @@
           <a:p>
             <a:fld id="{37013DEC-0FEE-4FF8-9051-DE981A23AC12}" type="datetimeFigureOut">
               <a:rPr lang="es-AR" smtClean="0"/>
-              <a:t>3/6/2026</a:t>
+              <a:t>22/6/2026</a:t>
             </a:fld>
             <a:endParaRPr lang="es-AR" dirty="0"/>
           </a:p>
@@ -3035,7 +3035,7 @@
           <a:p>
             <a:fld id="{37013DEC-0FEE-4FF8-9051-DE981A23AC12}" type="datetimeFigureOut">
               <a:rPr lang="es-AR" smtClean="0"/>
-              <a:t>3/6/2026</a:t>
+              <a:t>22/6/2026</a:t>
             </a:fld>
             <a:endParaRPr lang="es-AR" dirty="0"/>
           </a:p>
@@ -3130,7 +3130,7 @@
           <a:p>
             <a:fld id="{37013DEC-0FEE-4FF8-9051-DE981A23AC12}" type="datetimeFigureOut">
               <a:rPr lang="es-AR" smtClean="0"/>
-              <a:t>3/6/2026</a:t>
+              <a:t>22/6/2026</a:t>
             </a:fld>
             <a:endParaRPr lang="es-AR" dirty="0"/>
           </a:p>
@@ -3407,7 +3407,7 @@
           <a:p>
             <a:fld id="{37013DEC-0FEE-4FF8-9051-DE981A23AC12}" type="datetimeFigureOut">
               <a:rPr lang="es-AR" smtClean="0"/>
-              <a:t>3/6/2026</a:t>
+              <a:t>22/6/2026</a:t>
             </a:fld>
             <a:endParaRPr lang="es-AR" dirty="0"/>
           </a:p>
@@ -3660,7 +3660,7 @@
           <a:p>
             <a:fld id="{37013DEC-0FEE-4FF8-9051-DE981A23AC12}" type="datetimeFigureOut">
               <a:rPr lang="es-AR" smtClean="0"/>
-              <a:t>3/6/2026</a:t>
+              <a:t>22/6/2026</a:t>
             </a:fld>
             <a:endParaRPr lang="es-AR" dirty="0"/>
           </a:p>
@@ -3828,7 +3828,7 @@
           <a:p>
             <a:fld id="{669CF9DF-1B42-4005-BE0B-F4489D843B44}" type="datetime1">
               <a:rPr lang="es-ES" smtClean="0"/>
-              <a:t>03/06/2026</a:t>
+              <a:t>22/06/2026</a:t>
             </a:fld>
             <a:endParaRPr lang="es-ES" dirty="0"/>
           </a:p>
@@ -3998,7 +3998,7 @@
           <a:p>
             <a:fld id="{37013DEC-0FEE-4FF8-9051-DE981A23AC12}" type="datetimeFigureOut">
               <a:rPr lang="es-AR" smtClean="0"/>
-              <a:t>3/6/2026</a:t>
+              <a:t>22/6/2026</a:t>
             </a:fld>
             <a:endParaRPr lang="es-AR" dirty="0"/>
           </a:p>
@@ -4178,7 +4178,7 @@
           <a:p>
             <a:fld id="{37013DEC-0FEE-4FF8-9051-DE981A23AC12}" type="datetimeFigureOut">
               <a:rPr lang="es-AR" smtClean="0"/>
-              <a:t>3/6/2026</a:t>
+              <a:t>22/6/2026</a:t>
             </a:fld>
             <a:endParaRPr lang="es-AR" dirty="0"/>
           </a:p>
@@ -4423,7 +4423,7 @@
           <a:p>
             <a:fld id="{50661095-153F-4BE4-8633-EE56D76CA864}" type="datetime1">
               <a:rPr lang="es-ES" smtClean="0"/>
-              <a:t>03/06/2026</a:t>
+              <a:t>22/06/2026</a:t>
             </a:fld>
             <a:endParaRPr lang="es-ES" dirty="0"/>
           </a:p>
@@ -4708,7 +4708,7 @@
           <a:p>
             <a:fld id="{0185167F-B3C2-4DA8-9674-B15336757B83}" type="datetime1">
               <a:rPr lang="es-ES" smtClean="0"/>
-              <a:t>03/06/2026</a:t>
+              <a:t>22/06/2026</a:t>
             </a:fld>
             <a:endParaRPr lang="es-ES" dirty="0"/>
           </a:p>
@@ -5127,7 +5127,7 @@
           <a:p>
             <a:fld id="{1FEA0A98-1514-42DB-89DA-B5EA6B8FA61E}" type="datetime1">
               <a:rPr lang="es-ES" smtClean="0"/>
-              <a:t>03/06/2026</a:t>
+              <a:t>22/06/2026</a:t>
             </a:fld>
             <a:endParaRPr lang="es-ES" dirty="0"/>
           </a:p>
@@ -5244,7 +5244,7 @@
           <a:p>
             <a:fld id="{2D2F0422-C423-4D78-9178-62B717BC65E5}" type="datetime1">
               <a:rPr lang="es-ES" smtClean="0"/>
-              <a:t>03/06/2026</a:t>
+              <a:t>22/06/2026</a:t>
             </a:fld>
             <a:endParaRPr lang="es-ES" dirty="0"/>
           </a:p>
@@ -5339,7 +5339,7 @@
           <a:p>
             <a:fld id="{E780723B-F2CA-4EBC-A126-449EAF811C39}" type="datetime1">
               <a:rPr lang="es-ES" smtClean="0"/>
-              <a:t>03/06/2026</a:t>
+              <a:t>22/06/2026</a:t>
             </a:fld>
             <a:endParaRPr lang="es-ES" dirty="0"/>
           </a:p>
@@ -5614,7 +5614,7 @@
           <a:p>
             <a:fld id="{EC0120F4-783A-4250-877F-E0A6411B767E}" type="datetime1">
               <a:rPr lang="es-ES" smtClean="0"/>
-              <a:t>03/06/2026</a:t>
+              <a:t>22/06/2026</a:t>
             </a:fld>
             <a:endParaRPr lang="es-ES" dirty="0"/>
           </a:p>
@@ -5870,7 +5870,7 @@
           <a:p>
             <a:fld id="{AE927486-B8F2-4D10-B9C2-722D4A49DC5F}" type="datetime1">
               <a:rPr lang="es-ES" smtClean="0"/>
-              <a:t>03/06/2026</a:t>
+              <a:t>22/06/2026</a:t>
             </a:fld>
             <a:endParaRPr lang="es-ES" dirty="0"/>
           </a:p>
@@ -6081,7 +6081,7 @@
           <a:p>
             <a:fld id="{7ED72F16-78D9-4E02-8ABC-DA6468D0B2C6}" type="datetime1">
               <a:rPr lang="es-ES" smtClean="0"/>
-              <a:t>03/06/2026</a:t>
+              <a:t>22/06/2026</a:t>
             </a:fld>
             <a:endParaRPr lang="es-ES" dirty="0"/>
           </a:p>
@@ -6591,7 +6591,7 @@
           <a:p>
             <a:fld id="{37013DEC-0FEE-4FF8-9051-DE981A23AC12}" type="datetimeFigureOut">
               <a:rPr lang="es-AR" smtClean="0"/>
-              <a:t>3/6/2026</a:t>
+              <a:t>22/6/2026</a:t>
             </a:fld>
             <a:endParaRPr lang="es-AR" dirty="0"/>
           </a:p>
@@ -7271,58 +7271,6 @@
           </a:p>
         </p:txBody>
       </p:sp>
-      <p:pic>
-        <p:nvPicPr>
-          <p:cNvPr id="7" name="Picture 2" descr="C:\Users\jechazu\AppData\Local\Microsoft\Windows\Temporary Internet Files\Content.Outlook\6WIYSNXN\logo.png">
-            <a:extLst>
-              <a:ext uri="{FF2B5EF4-FFF2-40B4-BE49-F238E27FC236}">
-                <a16:creationId xmlns:a16="http://schemas.microsoft.com/office/drawing/2014/main" id="{CFB308BB-5084-467C-93C2-66524E1C9D22}"/>
-              </a:ext>
-            </a:extLst>
-          </p:cNvPr>
-          <p:cNvPicPr>
-            <a:picLocks noChangeAspect="1" noChangeArrowheads="1"/>
-          </p:cNvPicPr>
-          <p:nvPr/>
-        </p:nvPicPr>
-        <p:blipFill>
-          <a:blip r:embed="rId3">
-            <a:extLst>
-              <a:ext uri="{28A0092B-C50C-407E-A947-70E740481C1C}">
-                <a14:useLocalDpi xmlns:a14="http://schemas.microsoft.com/office/drawing/2010/main" val="0"/>
-              </a:ext>
-            </a:extLst>
-          </a:blip>
-          <a:srcRect/>
-          <a:stretch>
-            <a:fillRect/>
-          </a:stretch>
-        </p:blipFill>
-        <p:spPr bwMode="auto">
-          <a:xfrm>
-            <a:off x="3125598" y="620688"/>
-            <a:ext cx="2900210" cy="3295334"/>
-          </a:xfrm>
-          <a:prstGeom prst="rect">
-            <a:avLst/>
-          </a:prstGeom>
-          <a:noFill/>
-          <a:ln>
-            <a:solidFill>
-              <a:schemeClr val="tx1"/>
-            </a:solidFill>
-          </a:ln>
-          <a:extLst>
-            <a:ext uri="{909E8E84-426E-40DD-AFC4-6F175D3DCCD1}">
-              <a14:hiddenFill xmlns:a14="http://schemas.microsoft.com/office/drawing/2010/main">
-                <a:solidFill>
-                  <a:srgbClr val="FFFFFF"/>
-                </a:solidFill>
-              </a14:hiddenFill>
-            </a:ext>
-          </a:extLst>
-        </p:spPr>
-      </p:pic>
     </p:spTree>
     <p:extLst>
       <p:ext uri="{BB962C8B-B14F-4D97-AF65-F5344CB8AC3E}">
@@ -7548,47 +7496,6 @@
           </a:p>
         </p:txBody>
       </p:sp>
-      <p:pic>
-        <p:nvPicPr>
-          <p:cNvPr id="9" name="Imagen 8">
-            <a:extLst>
-              <a:ext uri="{FF2B5EF4-FFF2-40B4-BE49-F238E27FC236}">
-                <a16:creationId xmlns:a16="http://schemas.microsoft.com/office/drawing/2014/main" id="{69555BB6-EF18-4371-A2AE-695C91206753}"/>
-              </a:ext>
-            </a:extLst>
-          </p:cNvPr>
-          <p:cNvPicPr>
-            <a:picLocks noChangeAspect="1"/>
-          </p:cNvPicPr>
-          <p:nvPr/>
-        </p:nvPicPr>
-        <p:blipFill>
-          <a:blip r:embed="rId3">
-            <a:extLst>
-              <a:ext uri="{28A0092B-C50C-407E-A947-70E740481C1C}">
-                <a14:useLocalDpi xmlns:a14="http://schemas.microsoft.com/office/drawing/2010/main" val="0"/>
-              </a:ext>
-            </a:extLst>
-          </a:blip>
-          <a:stretch>
-            <a:fillRect/>
-          </a:stretch>
-        </p:blipFill>
-        <p:spPr>
-          <a:xfrm>
-            <a:off x="3125599" y="679633"/>
-            <a:ext cx="2900210" cy="3192941"/>
-          </a:xfrm>
-          <a:prstGeom prst="rect">
-            <a:avLst/>
-          </a:prstGeom>
-          <a:ln>
-            <a:solidFill>
-              <a:schemeClr val="tx1"/>
-            </a:solidFill>
-          </a:ln>
-        </p:spPr>
-      </p:pic>
     </p:spTree>
     <p:extLst>
       <p:ext uri="{BB962C8B-B14F-4D97-AF65-F5344CB8AC3E}">

</xml_diff>